<commit_message>
Demo video builder, cards, deck build
</commit_message>
<xml_diff>
--- a/deck/VibeRick-Dub.pptx
+++ b/deck/VibeRick-Dub.pptx
@@ -6957,7 +6957,7 @@
                 <a:cs typeface="Google Sans Flex"/>
                 <a:sym typeface="Google Sans Flex"/>
               </a:rPr>
-              <a:t>a. Team name: VibeRick</a:t>
+              <a:t>Team name: VibeRick</a:t>
             </a:r>
             <a:endParaRPr sz="1800">
               <a:latin typeface="Google Sans Flex"/>
@@ -6985,7 +6985,7 @@
                 <a:cs typeface="Google Sans Flex"/>
                 <a:sym typeface="Google Sans Flex"/>
               </a:rPr>
-              <a:t>b. Team leader name: Jaeho Shin</a:t>
+              <a:t>Team leader name: Jaeho Shin</a:t>
             </a:r>
             <a:endParaRPr sz="1800">
               <a:latin typeface="Google Sans Flex"/>
@@ -7013,7 +7013,7 @@
                 <a:cs typeface="Google Sans Flex"/>
                 <a:sym typeface="Google Sans Flex"/>
               </a:rPr>
-              <a:t>c. Problem Statement: Media, Content &amp; Digital Experiences — creators reach only the viewers who speak their language. VibeRick Dub turns one video into dubbed tracks in the creator's own voice.</a:t>
+              <a:t>Problem Statement: Media, Content &amp; Digital Experiences — creators reach only the viewers who speak their language. VibeRick Dub turns one video into dubbed tracks in the creator's own voice.</a:t>
             </a:r>
             <a:endParaRPr sz="1800">
               <a:latin typeface="Google Sans Flex"/>
@@ -7404,7 +7404,7 @@
                           </a:solidFill>
                           <a:latin typeface="Arial"/>
                         </a:rPr>
-                        <a:t>0.000</a:t>
+                        <a:t>0.008</a:t>
                       </a:r>
                     </a:p>
                   </a:txBody>
@@ -7588,7 +7588,7 @@
                           </a:solidFill>
                           <a:latin typeface="Arial"/>
                         </a:rPr>
-                        <a:t>≈ 0.02</a:t>
+                        <a:t>≈ 0.03</a:t>
                       </a:r>
                     </a:p>
                   </a:txBody>
@@ -7844,7 +7844,7 @@
                           </a:solidFill>
                           <a:latin typeface="Arial"/>
                         </a:rPr>
-                        <a:t>≈ 0.02</a:t>
+                        <a:t>≈ 0.03</a:t>
                       </a:r>
                     </a:p>
                   </a:txBody>
@@ -8351,7 +8351,7 @@
         </p:nvGraphicFramePr>
         <p:xfrm>
           <a:off x="265350" y="1180000"/>
-          <a:ext cx="8613300" cy="2640000"/>
+          <a:ext cx="8613300" cy="2970000"/>
         </p:xfrm>
         <a:graphic>
           <a:graphicData uri="http://schemas.openxmlformats.org/drawingml/2006/table">
@@ -8444,7 +8444,7 @@
                           </a:solidFill>
                           <a:latin typeface="Arial"/>
                         </a:rPr>
-                        <a:t>60 / 60</a:t>
+                        <a:t>69 / 69</a:t>
                       </a:r>
                     </a:p>
                   </a:txBody>
@@ -8490,7 +8490,7 @@
                           </a:solidFill>
                           <a:latin typeface="Arial"/>
                         </a:rPr>
-                        <a:t>0.13 s</a:t>
+                        <a:t>0.16 s</a:t>
                       </a:r>
                     </a:p>
                   </a:txBody>
@@ -8536,7 +8536,7 @@
                           </a:solidFill>
                           <a:latin typeface="Arial"/>
                         </a:rPr>
-                        <a:t>0:05</a:t>
+                        <a:t>2:52</a:t>
                       </a:r>
                     </a:p>
                   </a:txBody>
@@ -8560,7 +8560,7 @@
                           </a:solidFill>
                           <a:latin typeface="Arial"/>
                         </a:rPr>
-                        <a:t>2-speaker English podcast → Korean: lines verified; voices cast</a:t>
+                        <a:t>Full 15:05 video → 3 languages: verified · wall-clock</a:t>
                       </a:r>
                     </a:p>
                   </a:txBody>
@@ -8582,7 +8582,7 @@
                           </a:solidFill>
                           <a:latin typeface="Arial"/>
                         </a:rPr>
-                        <a:t>28 / 28 · male + female presets</a:t>
+                        <a:t>366 / 369 · 10:58</a:t>
                       </a:r>
                     </a:p>
                   </a:txBody>
@@ -8606,7 +8606,7 @@
                           </a:solidFill>
                           <a:latin typeface="Arial"/>
                         </a:rPr>
-                        <a:t>Transcript CER vs creator's edited captions (3 runs)</a:t>
+                        <a:t>2-speaker English podcast → Korean: lines verified; voices cast</a:t>
                       </a:r>
                     </a:p>
                   </a:txBody>
@@ -8628,7 +8628,7 @@
                           </a:solidFill>
                           <a:latin typeface="Arial"/>
                         </a:rPr>
-                        <a:t>Chirp 3 + Gemini 7.6–7.9% · Chirp 8.6% · Gemini 10.6–11.8%</a:t>
+                        <a:t>28 / 28 · male + female presets</a:t>
                       </a:r>
                     </a:p>
                   </a:txBody>
@@ -8652,7 +8652,7 @@
                           </a:solidFill>
                           <a:latin typeface="Arial"/>
                         </a:rPr>
-                        <a:t>Gemini-only timestamps drift (why Chirp is the clock)</a:t>
+                        <a:t>Transcript CER vs creator's edited captions (3 runs)</a:t>
                       </a:r>
                     </a:p>
                   </a:txBody>
@@ -8674,7 +8674,7 @@
                           </a:solidFill>
                           <a:latin typeface="Arial"/>
                         </a:rPr>
-                        <a:t>up to 42 s</a:t>
+                        <a:t>Chirp 3 + Gemini 7.6–7.9% · Chirp 8.6% · Gemini 10.6–11.8%</a:t>
                       </a:r>
                     </a:p>
                   </a:txBody>
@@ -8698,7 +8698,7 @@
                           </a:solidFill>
                           <a:latin typeface="Arial"/>
                         </a:rPr>
-                        <a:t>Speaker similarity to the creator (ECAPA cosine)</a:t>
+                        <a:t>Gemini-only timestamps drift (why Chirp is the clock)</a:t>
                       </a:r>
                     </a:p>
                   </a:txBody>
@@ -8720,13 +8720,59 @@
                           </a:solidFill>
                           <a:latin typeface="Arial"/>
                         </a:rPr>
+                        <a:t>up to 42 s</a:t>
+                      </a:r>
+                    </a:p>
+                  </a:txBody>
+                  <a:tcPr marL="70000" marR="70000" marT="30000" marB="30000">
+                    <a:solidFill>
+                      <a:srgbClr val="FFFFFF"/>
+                    </a:solidFill>
+                  </a:tcPr>
+                </a:tc>
+              </a:tr>
+              <a:tr h="330000">
+                <a:tc>
+                  <a:txBody>
+                    <a:bodyPr/>
+                    <a:lstStyle/>
+                    <a:p>
+                      <a:r>
+                        <a:rPr sz="1100" b="0">
+                          <a:solidFill>
+                            <a:srgbClr val="111214"/>
+                          </a:solidFill>
+                          <a:latin typeface="Arial"/>
+                        </a:rPr>
+                        <a:t>Speaker similarity to the creator (ECAPA cosine)</a:t>
+                      </a:r>
+                    </a:p>
+                  </a:txBody>
+                  <a:tcPr marL="70000" marR="70000" marT="30000" marB="30000">
+                    <a:solidFill>
+                      <a:srgbClr val="F3F6FF"/>
+                    </a:solidFill>
+                  </a:tcPr>
+                </a:tc>
+                <a:tc>
+                  <a:txBody>
+                    <a:bodyPr/>
+                    <a:lstStyle/>
+                    <a:p>
+                      <a:r>
+                        <a:rPr sz="1100" b="0">
+                          <a:solidFill>
+                            <a:srgbClr val="111214"/>
+                          </a:solidFill>
+                          <a:latin typeface="Arial"/>
+                        </a:rPr>
                         <a:t>English clone 0.68 · creator 0.90 · others 0.00–0.09</a:t>
                       </a:r>
                     </a:p>
                   </a:txBody>
                   <a:tcPr marL="70000" marR="70000" marT="30000" marB="30000">
                     <a:solidFill>
-                      <a:srgbClr val="FFFFFF"/>
+                      <a:srgbClr val="F3F6FF"/>
                     </a:solidFill>
                   </a:tcPr>
                 </a:tc>

</xml_diff>